<commit_message>
add technical audit suite for milestone verification and implement DDI service logic
</commit_message>
<xml_diff>
--- a/docs/presentation/GenMed_MidTerm.pptx
+++ b/docs/presentation/GenMed_MidTerm.pptx
@@ -5,17 +5,18 @@
     <p:sldMasterId id="2147483648" r:id="rId1"/>
   </p:sldMasterIdLst>
   <p:notesMasterIdLst>
-    <p:notesMasterId r:id="rId10"/>
+    <p:notesMasterId r:id="rId11"/>
   </p:notesMasterIdLst>
   <p:sldIdLst>
     <p:sldId id="256" r:id="rId2"/>
-    <p:sldId id="257" r:id="rId3"/>
-    <p:sldId id="258" r:id="rId4"/>
-    <p:sldId id="259" r:id="rId5"/>
-    <p:sldId id="260" r:id="rId6"/>
-    <p:sldId id="261" r:id="rId7"/>
-    <p:sldId id="262" r:id="rId8"/>
-    <p:sldId id="263" r:id="rId9"/>
+    <p:sldId id="264" r:id="rId3"/>
+    <p:sldId id="257" r:id="rId4"/>
+    <p:sldId id="258" r:id="rId5"/>
+    <p:sldId id="259" r:id="rId6"/>
+    <p:sldId id="260" r:id="rId7"/>
+    <p:sldId id="261" r:id="rId8"/>
+    <p:sldId id="262" r:id="rId9"/>
+    <p:sldId id="263" r:id="rId10"/>
   </p:sldIdLst>
   <p:sldSz cx="12192000" cy="6858000"/>
   <p:notesSz cx="6858000" cy="12192000"/>
@@ -393,7 +394,7 @@
           <a:p>
             <a:fld id="{F7021451-1387-4CA6-816F-3879F97B5CBC}" type="slidenum">
               <a:rPr lang="en-US"/>
-              <a:t>2</a:t>
+              <a:t>3</a:t>
             </a:fld>
             <a:endParaRPr lang="en-US"/>
           </a:p>
@@ -477,7 +478,7 @@
           <a:p>
             <a:fld id="{F7021451-1387-4CA6-816F-3879F97B5CBC}" type="slidenum">
               <a:rPr lang="en-US"/>
-              <a:t>3</a:t>
+              <a:t>4</a:t>
             </a:fld>
             <a:endParaRPr lang="en-US"/>
           </a:p>
@@ -561,7 +562,7 @@
           <a:p>
             <a:fld id="{F7021451-1387-4CA6-816F-3879F97B5CBC}" type="slidenum">
               <a:rPr lang="en-US"/>
-              <a:t>4</a:t>
+              <a:t>5</a:t>
             </a:fld>
             <a:endParaRPr lang="en-US"/>
           </a:p>
@@ -645,7 +646,7 @@
           <a:p>
             <a:fld id="{F7021451-1387-4CA6-816F-3879F97B5CBC}" type="slidenum">
               <a:rPr lang="en-US"/>
-              <a:t>5</a:t>
+              <a:t>6</a:t>
             </a:fld>
             <a:endParaRPr lang="en-US"/>
           </a:p>
@@ -729,7 +730,7 @@
           <a:p>
             <a:fld id="{F7021451-1387-4CA6-816F-3879F97B5CBC}" type="slidenum">
               <a:rPr lang="en-US"/>
-              <a:t>6</a:t>
+              <a:t>7</a:t>
             </a:fld>
             <a:endParaRPr lang="en-US"/>
           </a:p>
@@ -813,7 +814,7 @@
           <a:p>
             <a:fld id="{F7021451-1387-4CA6-816F-3879F97B5CBC}" type="slidenum">
               <a:rPr lang="en-US"/>
-              <a:t>7</a:t>
+              <a:t>8</a:t>
             </a:fld>
             <a:endParaRPr lang="en-US"/>
           </a:p>
@@ -897,7 +898,7 @@
           <a:p>
             <a:fld id="{F7021451-1387-4CA6-816F-3879F97B5CBC}" type="slidenum">
               <a:rPr lang="en-US"/>
-              <a:t>8</a:t>
+              <a:t>9</a:t>
             </a:fld>
             <a:endParaRPr lang="en-US"/>
           </a:p>
@@ -946,6 +947,101 @@
 </p:sldLayout>
 </file>
 
+<file path=ppt/slideLayouts/slideLayout2.xml><?xml version="1.0" encoding="utf-8"?>
+<p:sldLayout xmlns:a="http://schemas.openxmlformats.org/drawingml/2006/main" xmlns:r="http://schemas.openxmlformats.org/officeDocument/2006/relationships" xmlns:p="http://schemas.openxmlformats.org/presentationml/2006/main" type="blank">
+  <p:cSld name="Blank">
+    <p:spTree>
+      <p:nvGrpSpPr>
+        <p:cNvPr id="1" name=""/>
+        <p:cNvGrpSpPr/>
+        <p:nvPr/>
+      </p:nvGrpSpPr>
+      <p:grpSpPr>
+        <a:xfrm>
+          <a:off x="0" y="0"/>
+          <a:ext cx="0" cy="0"/>
+          <a:chOff x="0" y="0"/>
+          <a:chExt cx="0" cy="0"/>
+        </a:xfrm>
+      </p:grpSpPr>
+      <p:sp>
+        <p:nvSpPr>
+          <p:cNvPr id="2" name="Date Placeholder 1"/>
+          <p:cNvSpPr>
+            <a:spLocks noGrp="1"/>
+          </p:cNvSpPr>
+          <p:nvPr>
+            <p:ph type="dt" sz="half" idx="10"/>
+          </p:nvPr>
+        </p:nvSpPr>
+        <p:spPr/>
+        <p:txBody>
+          <a:bodyPr/>
+          <a:lstStyle/>
+          <a:p>
+            <a:fld id="{5BCAD085-E8A6-8845-BD4E-CB4CCA059FC4}" type="datetimeFigureOut">
+              <a:rPr lang="en-US" smtClean="0"/>
+              <a:t>8/31/2026</a:t>
+            </a:fld>
+            <a:endParaRPr lang="en-US"/>
+          </a:p>
+        </p:txBody>
+      </p:sp>
+      <p:sp>
+        <p:nvSpPr>
+          <p:cNvPr id="3" name="Footer Placeholder 2"/>
+          <p:cNvSpPr>
+            <a:spLocks noGrp="1"/>
+          </p:cNvSpPr>
+          <p:nvPr>
+            <p:ph type="ftr" sz="quarter" idx="11"/>
+          </p:nvPr>
+        </p:nvSpPr>
+        <p:spPr/>
+        <p:txBody>
+          <a:bodyPr/>
+          <a:lstStyle/>
+          <a:p>
+            <a:endParaRPr lang="en-US"/>
+          </a:p>
+        </p:txBody>
+      </p:sp>
+      <p:sp>
+        <p:nvSpPr>
+          <p:cNvPr id="4" name="Slide Number Placeholder 3"/>
+          <p:cNvSpPr>
+            <a:spLocks noGrp="1"/>
+          </p:cNvSpPr>
+          <p:nvPr>
+            <p:ph type="sldNum" sz="quarter" idx="12"/>
+          </p:nvPr>
+        </p:nvSpPr>
+        <p:spPr/>
+        <p:txBody>
+          <a:bodyPr/>
+          <a:lstStyle/>
+          <a:p>
+            <a:fld id="{C1FF6DA9-008F-8B48-92A6-B652298478BF}" type="slidenum">
+              <a:rPr lang="en-US" smtClean="0"/>
+              <a:t>‹#›</a:t>
+            </a:fld>
+            <a:endParaRPr lang="en-US"/>
+          </a:p>
+        </p:txBody>
+      </p:sp>
+    </p:spTree>
+    <p:extLst>
+      <p:ext uri="{BB962C8B-B14F-4D97-AF65-F5344CB8AC3E}">
+        <p14:creationId xmlns:p14="http://schemas.microsoft.com/office/powerpoint/2010/main" val="4049102387"/>
+      </p:ext>
+    </p:extLst>
+  </p:cSld>
+  <p:clrMapOvr>
+    <a:masterClrMapping/>
+  </p:clrMapOvr>
+</p:sldLayout>
+</file>
+
 <file path=ppt/slideMasters/slideMaster1.xml><?xml version="1.0" encoding="utf-8"?>
 <p:sldMaster xmlns:a="http://schemas.openxmlformats.org/drawingml/2006/main" xmlns:r="http://schemas.openxmlformats.org/officeDocument/2006/relationships" xmlns:p="http://schemas.openxmlformats.org/presentationml/2006/main">
   <p:cSld>
@@ -973,6 +1069,7 @@
   <p:clrMap bg1="lt1" tx1="dk1" bg2="lt2" tx2="dk2" accent1="accent1" accent2="accent2" accent3="accent3" accent4="accent4" accent5="accent5" accent6="accent6" hlink="hlink" folHlink="folHlink"/>
   <p:sldLayoutIdLst>
     <p:sldLayoutId id="2147483649" r:id="rId1"/>
+    <p:sldLayoutId id="2147483650" r:id="rId2"/>
   </p:sldLayoutIdLst>
   <p:hf sldNum="0" hdr="0" ftr="0" dt="0"/>
   <p:txStyles>
@@ -1558,6 +1655,138 @@
 
 <file path=ppt/slides/slide2.xml><?xml version="1.0" encoding="utf-8"?>
 <p:sld xmlns:a="http://schemas.openxmlformats.org/drawingml/2006/main" xmlns:r="http://schemas.openxmlformats.org/officeDocument/2006/relationships" xmlns:p="http://schemas.openxmlformats.org/presentationml/2006/main">
+  <p:cSld>
+    <p:spTree>
+      <p:nvGrpSpPr>
+        <p:cNvPr id="1" name=""/>
+        <p:cNvGrpSpPr/>
+        <p:nvPr/>
+      </p:nvGrpSpPr>
+      <p:grpSpPr>
+        <a:xfrm>
+          <a:off x="0" y="0"/>
+          <a:ext cx="0" cy="0"/>
+          <a:chOff x="0" y="0"/>
+          <a:chExt cx="0" cy="0"/>
+        </a:xfrm>
+      </p:grpSpPr>
+      <p:pic>
+        <p:nvPicPr>
+          <p:cNvPr id="2" name="Picture 1" descr="image.png"/>
+          <p:cNvPicPr>
+            <a:picLocks noChangeAspect="1"/>
+          </p:cNvPicPr>
+          <p:nvPr/>
+        </p:nvPicPr>
+        <p:blipFill>
+          <a:blip r:embed="rId2"/>
+          <a:stretch>
+            <a:fillRect/>
+          </a:stretch>
+        </p:blipFill>
+        <p:spPr>
+          <a:xfrm>
+            <a:off x="0" y="0"/>
+            <a:ext cx="12192000" cy="6858000"/>
+          </a:xfrm>
+          <a:prstGeom prst="rect">
+            <a:avLst/>
+          </a:prstGeom>
+        </p:spPr>
+      </p:pic>
+      <p:pic>
+        <p:nvPicPr>
+          <p:cNvPr id="3" name="Picture 2" descr="image.png"/>
+          <p:cNvPicPr>
+            <a:picLocks noChangeAspect="1"/>
+          </p:cNvPicPr>
+          <p:nvPr/>
+        </p:nvPicPr>
+        <p:blipFill>
+          <a:blip r:embed="rId3"/>
+          <a:stretch>
+            <a:fillRect/>
+          </a:stretch>
+        </p:blipFill>
+        <p:spPr>
+          <a:xfrm>
+            <a:off x="571500" y="1524000"/>
+            <a:ext cx="11049000" cy="4762500"/>
+          </a:xfrm>
+          <a:prstGeom prst="rect">
+            <a:avLst/>
+          </a:prstGeom>
+        </p:spPr>
+      </p:pic>
+      <p:pic>
+        <p:nvPicPr>
+          <p:cNvPr id="4" name="Picture 3" descr="image.png"/>
+          <p:cNvPicPr>
+            <a:picLocks noChangeAspect="1"/>
+          </p:cNvPicPr>
+          <p:nvPr/>
+        </p:nvPicPr>
+        <p:blipFill>
+          <a:blip r:embed="rId4"/>
+          <a:stretch>
+            <a:fillRect/>
+          </a:stretch>
+        </p:blipFill>
+        <p:spPr>
+          <a:xfrm>
+            <a:off x="719216" y="5898059"/>
+            <a:ext cx="9944100" cy="959941"/>
+          </a:xfrm>
+          <a:prstGeom prst="rect">
+            <a:avLst/>
+          </a:prstGeom>
+        </p:spPr>
+      </p:pic>
+      <p:sp>
+        <p:nvSpPr>
+          <p:cNvPr id="5" name="TextBox 4"/>
+          <p:cNvSpPr txBox="1"/>
+          <p:nvPr/>
+        </p:nvSpPr>
+        <p:spPr>
+          <a:xfrm>
+            <a:off x="571500" y="571500"/>
+            <a:ext cx="11601450" cy="571500"/>
+          </a:xfrm>
+          <a:prstGeom prst="rect">
+            <a:avLst/>
+          </a:prstGeom>
+          <a:noFill/>
+        </p:spPr>
+        <p:txBody>
+          <a:bodyPr wrap="square" lIns="0" tIns="0" rIns="0" bIns="0" anchor="t">
+            <a:spAutoFit/>
+          </a:bodyPr>
+          <a:lstStyle/>
+          <a:p>
+            <a:pPr algn="l"/>
+            <a:r>
+              <a:rPr sz="3000" b="0" i="0" u="none">
+                <a:solidFill>
+                  <a:srgbClr val="1E3A8A"/>
+                </a:solidFill>
+                <a:latin typeface="Poppins SemiBold"/>
+              </a:rPr>
+              <a:t>Cost Savings Analysis (Per Strip)</a:t>
+            </a:r>
+          </a:p>
+        </p:txBody>
+      </p:sp>
+    </p:spTree>
+  </p:cSld>
+  <p:clrMapOvr>
+    <a:masterClrMapping/>
+  </p:clrMapOvr>
+</p:sld>
+</file>
+
+<file path=ppt/slides/slide3.xml><?xml version="1.0" encoding="utf-8"?>
+<p:sld xmlns:a="http://schemas.openxmlformats.org/drawingml/2006/main" xmlns:r="http://schemas.openxmlformats.org/officeDocument/2006/relationships" xmlns:p="http://schemas.openxmlformats.org/presentationml/2006/main">
   <p:cSld name="Slide 2">
     <p:bg>
       <p:bgPr>
@@ -2264,7 +2493,7 @@
 </p:sld>
 </file>
 
-<file path=ppt/slides/slide3.xml><?xml version="1.0" encoding="utf-8"?>
+<file path=ppt/slides/slide4.xml><?xml version="1.0" encoding="utf-8"?>
 <p:sld xmlns:a="http://schemas.openxmlformats.org/drawingml/2006/main" xmlns:r="http://schemas.openxmlformats.org/officeDocument/2006/relationships" xmlns:p="http://schemas.openxmlformats.org/presentationml/2006/main">
   <p:cSld name="Slide 3">
     <p:bg>
@@ -2361,7 +2590,7 @@
                 <a:ea typeface="Calibri" pitchFamily="34" charset="-122"/>
                 <a:cs typeface="Calibri" pitchFamily="34" charset="-120"/>
               </a:rPr>
-              <a:t>No internet needed — everything runs on the local machine, instantly</a:t>
+              <a:t>everything runs on the local machine, instantly</a:t>
             </a:r>
             <a:endParaRPr lang="en-US" sz="1400" dirty="0"/>
           </a:p>
@@ -3125,7 +3354,7 @@
 </p:sld>
 </file>
 
-<file path=ppt/slides/slide4.xml><?xml version="1.0" encoding="utf-8"?>
+<file path=ppt/slides/slide5.xml><?xml version="1.0" encoding="utf-8"?>
 <p:sld xmlns:a="http://schemas.openxmlformats.org/drawingml/2006/main" xmlns:r="http://schemas.openxmlformats.org/officeDocument/2006/relationships" xmlns:p="http://schemas.openxmlformats.org/presentationml/2006/main">
   <p:cSld name="Slide 4">
     <p:bg>
@@ -3946,7 +4175,7 @@
 </p:sld>
 </file>
 
-<file path=ppt/slides/slide5.xml><?xml version="1.0" encoding="utf-8"?>
+<file path=ppt/slides/slide6.xml><?xml version="1.0" encoding="utf-8"?>
 <p:sld xmlns:a="http://schemas.openxmlformats.org/drawingml/2006/main" xmlns:r="http://schemas.openxmlformats.org/officeDocument/2006/relationships" xmlns:p="http://schemas.openxmlformats.org/presentationml/2006/main">
   <p:cSld name="Slide 5">
     <p:bg>
@@ -4744,7 +4973,7 @@
 </p:sld>
 </file>
 
-<file path=ppt/slides/slide6.xml><?xml version="1.0" encoding="utf-8"?>
+<file path=ppt/slides/slide7.xml><?xml version="1.0" encoding="utf-8"?>
 <p:sld xmlns:a="http://schemas.openxmlformats.org/drawingml/2006/main" xmlns:r="http://schemas.openxmlformats.org/officeDocument/2006/relationships" xmlns:p="http://schemas.openxmlformats.org/presentationml/2006/main">
   <p:cSld name="Slide 6">
     <p:bg>
@@ -5595,7 +5824,7 @@
 </p:sld>
 </file>
 
-<file path=ppt/slides/slide7.xml><?xml version="1.0" encoding="utf-8"?>
+<file path=ppt/slides/slide8.xml><?xml version="1.0" encoding="utf-8"?>
 <p:sld xmlns:a="http://schemas.openxmlformats.org/drawingml/2006/main" xmlns:r="http://schemas.openxmlformats.org/officeDocument/2006/relationships" xmlns:p="http://schemas.openxmlformats.org/presentationml/2006/main">
   <p:cSld name="Slide 7">
     <p:bg>
@@ -6396,7 +6625,7 @@
 </p:sld>
 </file>
 
-<file path=ppt/slides/slide8.xml><?xml version="1.0" encoding="utf-8"?>
+<file path=ppt/slides/slide9.xml><?xml version="1.0" encoding="utf-8"?>
 <p:sld xmlns:a="http://schemas.openxmlformats.org/drawingml/2006/main" xmlns:r="http://schemas.openxmlformats.org/officeDocument/2006/relationships" xmlns:p="http://schemas.openxmlformats.org/presentationml/2006/main">
   <p:cSld name="Slide 8">
     <p:bg>

</xml_diff>

<commit_message>
some bug fixes and adding a better exact match algorithm
</commit_message>
<xml_diff>
--- a/docs/presentation/GenMed_MidTerm.pptx
+++ b/docs/presentation/GenMed_MidTerm.pptx
@@ -5,7 +5,7 @@
     <p:sldMasterId id="2147483648" r:id="rId1"/>
   </p:sldMasterIdLst>
   <p:notesMasterIdLst>
-    <p:notesMasterId r:id="rId11"/>
+    <p:notesMasterId r:id="rId14"/>
   </p:notesMasterIdLst>
   <p:sldIdLst>
     <p:sldId id="256" r:id="rId2"/>
@@ -17,6 +17,9 @@
     <p:sldId id="261" r:id="rId8"/>
     <p:sldId id="262" r:id="rId9"/>
     <p:sldId id="263" r:id="rId10"/>
+    <p:sldId id="265" r:id="rId11"/>
+    <p:sldId id="266" r:id="rId12"/>
+    <p:sldId id="267" r:id="rId13"/>
   </p:sldIdLst>
   <p:sldSz cx="12192000" cy="6858000"/>
   <p:notesSz cx="6858000" cy="12192000"/>
@@ -1646,6 +1649,186 @@
         </p:txBody>
       </p:sp>
     </p:spTree>
+  </p:cSld>
+  <p:clrMapOvr>
+    <a:masterClrMapping/>
+  </p:clrMapOvr>
+</p:sld>
+</file>
+
+<file path=ppt/slides/slide10.xml><?xml version="1.0" encoding="utf-8"?>
+<p:sld xmlns:a="http://schemas.openxmlformats.org/drawingml/2006/main" xmlns:r="http://schemas.openxmlformats.org/officeDocument/2006/relationships" xmlns:p="http://schemas.openxmlformats.org/presentationml/2006/main">
+  <p:cSld>
+    <p:spTree>
+      <p:nvGrpSpPr>
+        <p:cNvPr id="1" name=""/>
+        <p:cNvGrpSpPr/>
+        <p:nvPr/>
+      </p:nvGrpSpPr>
+      <p:grpSpPr>
+        <a:xfrm>
+          <a:off x="0" y="0"/>
+          <a:ext cx="0" cy="0"/>
+          <a:chOff x="0" y="0"/>
+          <a:chExt cx="0" cy="0"/>
+        </a:xfrm>
+      </p:grpSpPr>
+      <p:pic>
+        <p:nvPicPr>
+          <p:cNvPr id="3" name="Picture 2">
+            <a:extLst>
+              <a:ext uri="{FF2B5EF4-FFF2-40B4-BE49-F238E27FC236}">
+                <a16:creationId xmlns:a16="http://schemas.microsoft.com/office/drawing/2014/main" id="{39775C68-47FF-FC78-F914-568642B277F8}"/>
+              </a:ext>
+            </a:extLst>
+          </p:cNvPr>
+          <p:cNvPicPr>
+            <a:picLocks noChangeAspect="1"/>
+          </p:cNvPicPr>
+          <p:nvPr/>
+        </p:nvPicPr>
+        <p:blipFill>
+          <a:blip r:embed="rId2"/>
+          <a:stretch>
+            <a:fillRect/>
+          </a:stretch>
+        </p:blipFill>
+        <p:spPr>
+          <a:xfrm>
+            <a:off x="0" y="0"/>
+            <a:ext cx="12192000" cy="6705600"/>
+          </a:xfrm>
+          <a:prstGeom prst="rect">
+            <a:avLst/>
+          </a:prstGeom>
+        </p:spPr>
+      </p:pic>
+    </p:spTree>
+    <p:extLst>
+      <p:ext uri="{BB962C8B-B14F-4D97-AF65-F5344CB8AC3E}">
+        <p14:creationId xmlns:p14="http://schemas.microsoft.com/office/powerpoint/2010/main" val="810973821"/>
+      </p:ext>
+    </p:extLst>
+  </p:cSld>
+  <p:clrMapOvr>
+    <a:masterClrMapping/>
+  </p:clrMapOvr>
+</p:sld>
+</file>
+
+<file path=ppt/slides/slide11.xml><?xml version="1.0" encoding="utf-8"?>
+<p:sld xmlns:a="http://schemas.openxmlformats.org/drawingml/2006/main" xmlns:r="http://schemas.openxmlformats.org/officeDocument/2006/relationships" xmlns:p="http://schemas.openxmlformats.org/presentationml/2006/main">
+  <p:cSld>
+    <p:spTree>
+      <p:nvGrpSpPr>
+        <p:cNvPr id="1" name=""/>
+        <p:cNvGrpSpPr/>
+        <p:nvPr/>
+      </p:nvGrpSpPr>
+      <p:grpSpPr>
+        <a:xfrm>
+          <a:off x="0" y="0"/>
+          <a:ext cx="0" cy="0"/>
+          <a:chOff x="0" y="0"/>
+          <a:chExt cx="0" cy="0"/>
+        </a:xfrm>
+      </p:grpSpPr>
+      <p:pic>
+        <p:nvPicPr>
+          <p:cNvPr id="3" name="Picture 2">
+            <a:extLst>
+              <a:ext uri="{FF2B5EF4-FFF2-40B4-BE49-F238E27FC236}">
+                <a16:creationId xmlns:a16="http://schemas.microsoft.com/office/drawing/2014/main" id="{9B4DB798-2D76-9516-5937-693F7780D669}"/>
+              </a:ext>
+            </a:extLst>
+          </p:cNvPr>
+          <p:cNvPicPr>
+            <a:picLocks noChangeAspect="1"/>
+          </p:cNvPicPr>
+          <p:nvPr/>
+        </p:nvPicPr>
+        <p:blipFill>
+          <a:blip r:embed="rId2"/>
+          <a:stretch>
+            <a:fillRect/>
+          </a:stretch>
+        </p:blipFill>
+        <p:spPr>
+          <a:xfrm>
+            <a:off x="0" y="0"/>
+            <a:ext cx="12192000" cy="6857999"/>
+          </a:xfrm>
+          <a:prstGeom prst="rect">
+            <a:avLst/>
+          </a:prstGeom>
+        </p:spPr>
+      </p:pic>
+    </p:spTree>
+    <p:extLst>
+      <p:ext uri="{BB962C8B-B14F-4D97-AF65-F5344CB8AC3E}">
+        <p14:creationId xmlns:p14="http://schemas.microsoft.com/office/powerpoint/2010/main" val="654599859"/>
+      </p:ext>
+    </p:extLst>
+  </p:cSld>
+  <p:clrMapOvr>
+    <a:masterClrMapping/>
+  </p:clrMapOvr>
+</p:sld>
+</file>
+
+<file path=ppt/slides/slide12.xml><?xml version="1.0" encoding="utf-8"?>
+<p:sld xmlns:a="http://schemas.openxmlformats.org/drawingml/2006/main" xmlns:r="http://schemas.openxmlformats.org/officeDocument/2006/relationships" xmlns:p="http://schemas.openxmlformats.org/presentationml/2006/main">
+  <p:cSld>
+    <p:spTree>
+      <p:nvGrpSpPr>
+        <p:cNvPr id="1" name=""/>
+        <p:cNvGrpSpPr/>
+        <p:nvPr/>
+      </p:nvGrpSpPr>
+      <p:grpSpPr>
+        <a:xfrm>
+          <a:off x="0" y="0"/>
+          <a:ext cx="0" cy="0"/>
+          <a:chOff x="0" y="0"/>
+          <a:chExt cx="0" cy="0"/>
+        </a:xfrm>
+      </p:grpSpPr>
+      <p:pic>
+        <p:nvPicPr>
+          <p:cNvPr id="3" name="Picture 2">
+            <a:extLst>
+              <a:ext uri="{FF2B5EF4-FFF2-40B4-BE49-F238E27FC236}">
+                <a16:creationId xmlns:a16="http://schemas.microsoft.com/office/drawing/2014/main" id="{6DBCDD69-6990-DCCA-9738-988014441C26}"/>
+              </a:ext>
+            </a:extLst>
+          </p:cNvPr>
+          <p:cNvPicPr>
+            <a:picLocks noChangeAspect="1"/>
+          </p:cNvPicPr>
+          <p:nvPr/>
+        </p:nvPicPr>
+        <p:blipFill>
+          <a:blip r:embed="rId2"/>
+          <a:stretch>
+            <a:fillRect/>
+          </a:stretch>
+        </p:blipFill>
+        <p:spPr>
+          <a:xfrm>
+            <a:off x="0" y="269824"/>
+            <a:ext cx="12192000" cy="6160956"/>
+          </a:xfrm>
+          <a:prstGeom prst="rect">
+            <a:avLst/>
+          </a:prstGeom>
+        </p:spPr>
+      </p:pic>
+    </p:spTree>
+    <p:extLst>
+      <p:ext uri="{BB962C8B-B14F-4D97-AF65-F5344CB8AC3E}">
+        <p14:creationId xmlns:p14="http://schemas.microsoft.com/office/powerpoint/2010/main" val="382340957"/>
+      </p:ext>
+    </p:extLst>
   </p:cSld>
   <p:clrMapOvr>
     <a:masterClrMapping/>

</xml_diff>